<commit_message>
v3.3.1 - CRY-9 refinement x30: content depth 24 articles >2.5K + related links, deck bullet/title sharpening + 8 pptx resync, WCAG contrast/placeholder/reduced-motion/heading-hierarchy, unified footers, dead GitHub repo links fixed, deck viewer overlap fix, SEO meta, README v3.3
</commit_message>
<xml_diff>
--- a/decks/etl-playbook.pptx
+++ b/decks/etl-playbook.pptx
@@ -2109,7 +2109,7 @@
           <a:p>
             <a:r>
               <a:rPr lang="en-US" dirty="0"/>
-              <a:t>Key message: What this deck covers | Agenda: Why ETL fails quietly - and why silent is the default state; The arena: one datalake serving four countries of retail BI; Profiling sources and reconciling at every seam; Instrumenting schedules and giving discrepancies owners; What a trustworthy pipeline looks like in daily operation | Transition: next up - "ETL fails quietly".</a:t>
+              <a:t>Key message: What this deck covers | Agenda: Why ETL fails quietly - and why silent is the default state; The arena: one datalake serving four countries of retail BI; Profiling sources and reconciling at every seam; Instrumenting schedules and giving discrepancies owners; What a trustworthy pipeline looks like in daily operation | Transition: next up - "ETL fails quietly, and quiet is expensive".</a:t>
             </a:r>
             <a:endParaRPr lang="en-US" dirty="0"/>
           </a:p>
@@ -2197,7 +2197,7 @@
           <a:p>
             <a:r>
               <a:rPr lang="en-US" dirty="0"/>
-              <a:t>Key message: ETL fails quietly | Talk track: Every principle in this playbook exists to make failure loud. | Transition: next up - "Regional BI across four countries, one datalake".</a:t>
+              <a:t>Key message: ETL fails quietly, and quiet is expensive | Talk track: Every principle in this playbook exists to make failure loud. | Transition: next up - "Regional BI across four countries, one datalake".</a:t>
             </a:r>
             <a:endParaRPr lang="en-US" dirty="0"/>
           </a:p>
@@ -6856,7 +6856,7 @@
                 <a:ea typeface="Segoe UI" pitchFamily="34" charset="-122"/>
                 <a:cs typeface="Segoe UI" pitchFamily="34" charset="-120"/>
               </a:rPr>
-              <a:t>ETL fails quietly</a:t>
+              <a:t>ETL fails quietly, and quiet is expensive</a:t>
             </a:r>
             <a:endParaRPr lang="en-US" sz="2700" dirty="0"/>
           </a:p>

</xml_diff>